<commit_message>
Drop em dashes across the deck and tighten the phrasing
Replaced with periods, colons or commas depending on what the sentence needed.
Verified zero remain in slide bodies, tables, figure titles and speaker notes.
</commit_message>
<xml_diff>
--- a/slides/ME344_Final_Arnold_Hambuch.pptx
+++ b/slides/ME344_Final_Arnold_Hambuch.pptx
@@ -528,7 +528,7 @@
           </a:p>
           <a:p>
             <a:r>
-              <a:t>codes — the physician confirms each one before anything is written, which is a</a:t>
+              <a:t>codes, the physician confirms each one before anything is written, which is a</a:t>
             </a:r>
           </a:p>
           <a:p>
@@ -554,7 +554,7 @@
           </a:p>
           <a:p>
             <a:r>
-              <a:t>infrastructure question, not a model question — so we built the workload and</a:t>
+              <a:t>infrastructure question, not a model question, so we built the workload and</a:t>
             </a:r>
           </a:p>
           <a:p>
@@ -586,7 +586,7 @@
           </a:p>
           <a:p>
             <a:r>
-              <a:t>studying is where the time goes — and what it takes to run the job at all."</a:t>
+              <a:t>studying is where the time goes, and what it takes to run the job at all."</a:t>
             </a:r>
           </a:p>
         </p:txBody>
@@ -667,7 +667,7 @@
           </a:p>
           <a:p>
             <a:r>
-              <a:t>lowers it to three different backends. No per-backend reimplementation — that is</a:t>
+              <a:t>lowers it to three different backends. No per-backend reimplementation, that is</a:t>
             </a:r>
           </a:p>
           <a:p>
@@ -704,7 +704,7 @@
           </a:p>
           <a:p>
             <a:r>
-              <a:t>cache as a knob instead of fixing it — because that knob turned out to be the</a:t>
+              <a:t>cache as a knob instead of fixing it, because that knob turned out to be the</a:t>
             </a:r>
           </a:p>
           <a:p>
@@ -812,7 +812,7 @@
           </a:p>
           <a:p>
             <a:r>
-              <a:t>wall clock apart into six phases — scheduling, image pull, checkpoint load, XLA</a:t>
+              <a:t>wall clock apart into six phases: scheduling, image pull, checkpoint load, XLA</a:t>
             </a:r>
           </a:p>
           <a:p>
@@ -844,7 +844,7 @@
           <a:p/>
           <a:p>
             <a:r>
-              <a:t>All of it writes against one fixed schema — one JSON per run — and every figure</a:t>
+              <a:t>All of it writes against one fixed schema, one JSON per run, and every figure</a:t>
             </a:r>
           </a:p>
           <a:p>
@@ -870,7 +870,7 @@
           </a:p>
           <a:p>
             <a:r>
-              <a:t>impossible — and it carried a passing status. What caught it was that the</a:t>
+              <a:t>impossible, and it carried a passing status. What caught it was that the</a:t>
             </a:r>
           </a:p>
           <a:p>
@@ -955,7 +955,7 @@
           <a:lstStyle/>
           <a:p>
             <a:r>
-              <a:t>LUIS  (~85 s — this is the slide to spend time on)</a:t>
+              <a:t>LUIS  (~85 s, the slide to spend time on)</a:t>
             </a:r>
           </a:p>
           <a:p/>
@@ -977,7 +977,7 @@
           </a:p>
           <a:p>
             <a:r>
-              <a:t>slice to within a quarter of a percent. Not eight times slower — the same.</a:t>
+              <a:t>slice to within a quarter of a percent. Not eight times slower, the same.</a:t>
             </a:r>
           </a:p>
           <a:p/>
@@ -1009,12 +1009,12 @@
           </a:p>
           <a:p>
             <a:r>
-              <a:t>the largest single phase, enabled the gcsfuse file cache — one line in the</a:t>
-            </a:r>
-          </a:p>
-          <a:p>
-            <a:r>
-              <a:t>manifest — and re-ran. Load dropped fourteen and a half times. Total wall clock</a:t>
+              <a:t>the largest single phase, enabled the gcsfuse file cache, one line in the</a:t>
+            </a:r>
+          </a:p>
+          <a:p>
+            <a:r>
+              <a:t>manifest, and re-ran. Load dropped fourteen and a half times. Total wall clock</a:t>
             </a:r>
           </a:p>
           <a:p>
@@ -1035,7 +1035,7 @@
           </a:p>
           <a:p>
             <a:r>
-              <a:t>change at all. Only I/O moved — which is why we can attribute the saving to the</a:t>
+              <a:t>change at all. Only I/O moved, which is why we can attribute the saving to the</a:t>
             </a:r>
           </a:p>
           <a:p>
@@ -1154,7 +1154,7 @@
           </a:p>
           <a:p>
             <a:r>
-              <a:t>cost. Going from 0.6 to 4 billion parameters — under seven times — did not make</a:t>
+              <a:t>cost. Going from 0.6 to 4 billion parameters, under seven times, did not make</a:t>
             </a:r>
           </a:p>
           <a:p>
@@ -1201,7 +1201,7 @@
           <a:p/>
           <a:p>
             <a:r>
-              <a:t>So the recommendation is not to scale out — it is to amortise. Raise the batch</a:t>
+              <a:t>So the recommendation is not to scale out, it is to amortise. Raise the batch</a:t>
             </a:r>
           </a:p>
           <a:p>
@@ -1227,7 +1227,7 @@
           </a:p>
           <a:p>
             <a:r>
-              <a:t>fixed overhead per job — and that is an architecture decision, not a hardware</a:t>
+              <a:t>fixed overhead per job, and that is an architecture decision, not a hardware</a:t>
             </a:r>
           </a:p>
           <a:p>
@@ -4483,7 +4483,7 @@
                 </a:solidFill>
                 <a:latin typeface="Helvetica Neue"/>
               </a:rPr>
-              <a:t>Dr. Findus — our startup, Berlin</a:t>
+              <a:t>Dr. Findus, our startup in Berlin</a:t>
             </a:r>
           </a:p>
         </p:txBody>
@@ -4554,7 +4554,7 @@
                 </a:solidFill>
                 <a:latin typeface="Helvetica Neue"/>
               </a:rPr>
-              <a:t>the physician confirms each one — a legal</a:t>
+              <a:t>the physician confirms each one. A legal</a:t>
             </a:r>
           </a:p>
           <a:p>
@@ -4680,7 +4680,7 @@
                 </a:solidFill>
                 <a:latin typeface="Helvetica Neue"/>
               </a:rPr>
-              <a:t>An infrastructure question, not a model one —</a:t>
+              <a:t>An infrastructure question, not a model one.</a:t>
             </a:r>
           </a:p>
           <a:p>
@@ -4916,7 +4916,7 @@
                 </a:solidFill>
                 <a:latin typeface="Helvetica Neue"/>
               </a:rPr>
-              <a:t>tokens in the longest case —</a:t>
+              <a:t>tokens in the longest case.</a:t>
             </a:r>
           </a:p>
           <a:p>
@@ -4932,7 +4932,7 @@
                 </a:solidFill>
                 <a:latin typeface="Helvetica Neue"/>
               </a:rPr>
-              <a:t>sequence length is not free</a:t>
+              <a:t>Sequence length is not free</a:t>
             </a:r>
           </a:p>
         </p:txBody>
@@ -5065,7 +5065,7 @@
                 </a:solidFill>
                 <a:latin typeface="Helvetica Neue"/>
               </a:rPr>
-              <a:t>Where does the time actually go — and what does it take to run this at all?</a:t>
+              <a:t>Where does the time actually go, and what does it take to run this at all?</a:t>
             </a:r>
           </a:p>
         </p:txBody>
@@ -5104,7 +5104,7 @@
                 </a:solidFill>
                 <a:latin typeface="Helvetica Neue"/>
               </a:rPr>
-              <a:t>No patient data was used. Model accuracy earns no marks here — the object of study is the infrastructure.</a:t>
+              <a:t>No patient data was used. Model accuracy earns no marks here. The object of study is the infrastructure.</a:t>
             </a:r>
           </a:p>
         </p:txBody>
@@ -5469,7 +5469,7 @@
                 </a:solidFill>
                 <a:latin typeface="Helvetica Neue"/>
               </a:rPr>
-              <a:t>Tunix — no per-backend</a:t>
+              <a:t>Tunix, no per-backend</a:t>
             </a:r>
           </a:p>
           <a:p>
@@ -5881,7 +5881,7 @@
                 </a:solidFill>
                 <a:latin typeface="Helvetica Neue"/>
               </a:rPr>
-              <a:t>knob rather than fixed —</a:t>
+              <a:t>knob rather than fixed -</a:t>
             </a:r>
           </a:p>
           <a:p>
@@ -6261,7 +6261,7 @@
                           </a:solidFill>
                           <a:latin typeface="Helvetica Neue"/>
                         </a:rPr>
-                        <a:t>v5e 2×4 — 8 chips</a:t>
+                        <a:t>v5e 2×4, 8 chips</a:t>
                       </a:r>
                     </a:p>
                   </a:txBody>
@@ -6586,7 +6586,7 @@
                 </a:solidFill>
                 <a:latin typeface="Helvetica Neue"/>
               </a:rPr>
-              <a:t>into six phases — scheduling, image pull,</a:t>
+              <a:t>into six phases: scheduling, image pull,</a:t>
             </a:r>
           </a:p>
           <a:p>
@@ -6682,7 +6682,7 @@
                 </a:solidFill>
                 <a:latin typeface="Helvetica Neue"/>
               </a:rPr>
-              <a:t>never dropped — the boundary is the</a:t>
+              <a:t>never dropped. The boundary is the</a:t>
             </a:r>
           </a:p>
           <a:p>
@@ -6912,7 +6912,7 @@
                 </a:solidFill>
                 <a:latin typeface="Helvetica Neue"/>
               </a:rPr>
-              <a:t>Impossible — yet it carried status "ok".</a:t>
+              <a:t>Impossible, yet it carried status "ok".</a:t>
             </a:r>
           </a:p>
           <a:p>
@@ -7279,7 +7279,7 @@
                           </a:solidFill>
                           <a:latin typeface="Helvetica Neue"/>
                         </a:rPr>
-                        <a:t>—</a:t>
+                        <a:t>-</a:t>
                       </a:r>
                     </a:p>
                   </a:txBody>
@@ -7993,7 +7993,7 @@
                 </a:solidFill>
                 <a:latin typeface="Helvetica Neue"/>
               </a:rPr>
-              <a:t>manifest line — 31 % off wall clock</a:t>
+              <a:t>manifest line, 31 % off wall clock</a:t>
             </a:r>
           </a:p>
         </p:txBody>
@@ -8191,7 +8191,7 @@
                 </a:solidFill>
                 <a:latin typeface="Helvetica Neue"/>
               </a:rPr>
-              <a:t>1.75122 s  →  1.75117 s</a:t>
+              <a:t>1.75122 s  to  1.75117 s</a:t>
             </a:r>
           </a:p>
           <a:p>
@@ -8239,7 +8239,7 @@
                 </a:solidFill>
                 <a:latin typeface="Helvetica Neue"/>
               </a:rPr>
-              <a:t>Only I/O did — so the saving is</a:t>
+              <a:t>Only I/O did, so the saving is</a:t>
             </a:r>
           </a:p>
           <a:p>
@@ -8753,7 +8753,7 @@
                 </a:solidFill>
                 <a:latin typeface="Helvetica Neue"/>
               </a:rPr>
-              <a:t>more parameters — CPU stopped</a:t>
+              <a:t>more parameters, CPU stopped</a:t>
             </a:r>
           </a:p>
         </p:txBody>
@@ -8792,7 +8792,7 @@
                 </a:solidFill>
                 <a:latin typeface="Helvetica Neue"/>
               </a:rPr>
-              <a:t>0.6B → 4B did not make the CPU</a:t>
+              <a:t>0.6B to 4B did not make the CPU</a:t>
             </a:r>
           </a:p>
           <a:p>
@@ -9131,7 +9131,7 @@
                 </a:solidFill>
                 <a:latin typeface="Helvetica Neue"/>
               </a:rPr>
-              <a:t>Do not scale out — amortise. Raise batch only until</a:t>
+              <a:t>Do not scale out. Amortise: raise batch only until</a:t>
             </a:r>
           </a:p>
           <a:p>
@@ -9321,7 +9321,7 @@
                 </a:solidFill>
                 <a:latin typeface="Helvetica Neue"/>
               </a:rPr>
-              <a:t>At $0.131 per 1 000 steps on one GH200 —</a:t>
+              <a:t>At $0.131 per 1 000 steps on one GH200,</a:t>
             </a:r>
           </a:p>
           <a:p>
@@ -9353,7 +9353,7 @@
                 </a:solidFill>
                 <a:latin typeface="Helvetica Neue"/>
               </a:rPr>
-              <a:t>speed — self-hosting is not the cost problem we</a:t>
+              <a:t>speed, self-hosting is not the cost problem we</a:t>
             </a:r>
           </a:p>
           <a:p>

</xml_diff>